<commit_message>
Fix lesson blueprint links for customer distribution
Co-authored-by: Copilot <223556219+Copilot@users.noreply.github.com>
</commit_message>
<xml_diff>
--- a/lessons/session_03/presentation/session_03_low_code_fabric_data_engineering.pptx
+++ b/lessons/session_03/presentation/session_03_low_code_fabric_data_engineering.pptx
@@ -729,7 +729,7 @@
           </a:p>
           <a:p>
             <a:r>
-              <a:t>**Blueprint:** [Module 2](../session_3_blueprint.md#module-2-repeatable-ingestion---35-minutes)  </a:t>
+              <a:t>**Blueprint:** [Module 2](../../session_3_blueprint.md#module-2-repeatable-ingestion---35-minutes)  </a:t>
             </a:r>
           </a:p>
           <a:p>
@@ -2094,7 +2094,7 @@
           </a:p>
           <a:p>
             <a:r>
-              <a:t>**Blueprint:** [Module 3](../session_3_blueprint.md#module-3-curated-sql-engineering---50-minutes)  </a:t>
+              <a:t>**Blueprint:** [Module 3](../../session_3_blueprint.md#module-3-curated-sql-engineering---50-minutes)  </a:t>
             </a:r>
           </a:p>
           <a:p>
@@ -4461,7 +4461,7 @@
           </a:p>
           <a:p>
             <a:r>
-              <a:t>**Blueprint:** [Module 4](../session_3_blueprint.md#module-4-consumption-architecture---35-minutes)  </a:t>
+              <a:t>**Blueprint:** [Module 4](../../session_3_blueprint.md#module-4-consumption-architecture---35-minutes)  </a:t>
             </a:r>
           </a:p>
           <a:p>
@@ -5746,7 +5746,7 @@
           </a:p>
           <a:p>
             <a:r>
-              <a:t>**Blueprint:** [Module 1](../session_3_blueprint.md#module-1-architecture-decision-framework---25-minutes)  </a:t>
+              <a:t>**Blueprint:** [Module 1](../../session_3_blueprint.md#module-1-architecture-decision-framework---25-minutes)  </a:t>
             </a:r>
           </a:p>
           <a:p>
@@ -6315,7 +6315,7 @@
           </a:p>
           <a:p>
             <a:r>
-              <a:t>**Blueprint:** [Module 5](../session_3_blueprint.md#module-5-operations-and-gcc-high-findings---25-minutes)  </a:t>
+              <a:t>**Blueprint:** [Module 5](../../session_3_blueprint.md#module-5-operations-and-gcc-high-findings---25-minutes)  </a:t>
             </a:r>
           </a:p>
           <a:p>
@@ -7543,7 +7543,7 @@
           </a:p>
           <a:p>
             <a:r>
-              <a:t>**Blueprint:** [Module 6](../session_3_blueprint.md#module-6-exit-review---10-minutes)  </a:t>
+              <a:t>**Blueprint:** [Module 6](../../session_3_blueprint.md#module-6-exit-review---10-minutes)  </a:t>
             </a:r>
           </a:p>
           <a:p>
@@ -7883,7 +7883,7 @@
           </a:p>
           <a:p>
             <a:r>
-              <a:t>**Session outline:** [Session 3 blueprint](../session_3_blueprint.md)</a:t>
+              <a:t>**Session outline:** [Session 3 blueprint](../../session_3_blueprint.md)</a:t>
             </a:r>
           </a:p>
           <a:p/>

</xml_diff>